<commit_message>
Deploy: Update MMC config, parser logic, and homepage
</commit_message>
<xml_diff>
--- a/desktop_app/template.pptx
+++ b/desktop_app/template.pptx
@@ -227,7 +227,7 @@
           <a:p>
             <a:fld id="{59D5F835-45A3-457E-8B78-F3D5C8B7457F}" type="datetimeFigureOut">
               <a:rPr lang="en-US" smtClean="0"/>
-              <a:t>7/21/2026</a:t>
+              <a:t>8/17/2026</a:t>
             </a:fld>
             <a:endParaRPr lang="en-US"/>
           </a:p>
@@ -809,7 +809,7 @@
           <a:p>
             <a:fld id="{76F9A3AD-E74E-40F3-A091-AD7A5FD22E1E}" type="datetimeFigureOut">
               <a:rPr lang="en-US" smtClean="0"/>
-              <a:t>7/21/2026</a:t>
+              <a:t>8/17/2026</a:t>
             </a:fld>
             <a:endParaRPr lang="en-US"/>
           </a:p>
@@ -1007,7 +1007,7 @@
           <a:p>
             <a:fld id="{76F9A3AD-E74E-40F3-A091-AD7A5FD22E1E}" type="datetimeFigureOut">
               <a:rPr lang="en-US" smtClean="0"/>
-              <a:t>7/21/2026</a:t>
+              <a:t>8/17/2026</a:t>
             </a:fld>
             <a:endParaRPr lang="en-US"/>
           </a:p>
@@ -1215,7 +1215,7 @@
           <a:p>
             <a:fld id="{76F9A3AD-E74E-40F3-A091-AD7A5FD22E1E}" type="datetimeFigureOut">
               <a:rPr lang="en-US" smtClean="0"/>
-              <a:t>7/21/2026</a:t>
+              <a:t>8/17/2026</a:t>
             </a:fld>
             <a:endParaRPr lang="en-US"/>
           </a:p>
@@ -1413,7 +1413,7 @@
           <a:p>
             <a:fld id="{76F9A3AD-E74E-40F3-A091-AD7A5FD22E1E}" type="datetimeFigureOut">
               <a:rPr lang="en-US" smtClean="0"/>
-              <a:t>7/21/2026</a:t>
+              <a:t>8/17/2026</a:t>
             </a:fld>
             <a:endParaRPr lang="en-US"/>
           </a:p>
@@ -1688,7 +1688,7 @@
           <a:p>
             <a:fld id="{76F9A3AD-E74E-40F3-A091-AD7A5FD22E1E}" type="datetimeFigureOut">
               <a:rPr lang="en-US" smtClean="0"/>
-              <a:t>7/21/2026</a:t>
+              <a:t>8/17/2026</a:t>
             </a:fld>
             <a:endParaRPr lang="en-US"/>
           </a:p>
@@ -1953,7 +1953,7 @@
           <a:p>
             <a:fld id="{76F9A3AD-E74E-40F3-A091-AD7A5FD22E1E}" type="datetimeFigureOut">
               <a:rPr lang="en-US" smtClean="0"/>
-              <a:t>7/21/2026</a:t>
+              <a:t>8/17/2026</a:t>
             </a:fld>
             <a:endParaRPr lang="en-US"/>
           </a:p>
@@ -2365,7 +2365,7 @@
           <a:p>
             <a:fld id="{76F9A3AD-E74E-40F3-A091-AD7A5FD22E1E}" type="datetimeFigureOut">
               <a:rPr lang="en-US" smtClean="0"/>
-              <a:t>7/21/2026</a:t>
+              <a:t>8/17/2026</a:t>
             </a:fld>
             <a:endParaRPr lang="en-US"/>
           </a:p>
@@ -2506,7 +2506,7 @@
           <a:p>
             <a:fld id="{76F9A3AD-E74E-40F3-A091-AD7A5FD22E1E}" type="datetimeFigureOut">
               <a:rPr lang="en-US" smtClean="0"/>
-              <a:t>7/21/2026</a:t>
+              <a:t>8/17/2026</a:t>
             </a:fld>
             <a:endParaRPr lang="en-US"/>
           </a:p>
@@ -2619,7 +2619,7 @@
           <a:p>
             <a:fld id="{76F9A3AD-E74E-40F3-A091-AD7A5FD22E1E}" type="datetimeFigureOut">
               <a:rPr lang="en-US" smtClean="0"/>
-              <a:t>7/21/2026</a:t>
+              <a:t>8/17/2026</a:t>
             </a:fld>
             <a:endParaRPr lang="en-US"/>
           </a:p>
@@ -2930,7 +2930,7 @@
           <a:p>
             <a:fld id="{76F9A3AD-E74E-40F3-A091-AD7A5FD22E1E}" type="datetimeFigureOut">
               <a:rPr lang="en-US" smtClean="0"/>
-              <a:t>7/21/2026</a:t>
+              <a:t>8/17/2026</a:t>
             </a:fld>
             <a:endParaRPr lang="en-US"/>
           </a:p>
@@ -3218,7 +3218,7 @@
           <a:p>
             <a:fld id="{76F9A3AD-E74E-40F3-A091-AD7A5FD22E1E}" type="datetimeFigureOut">
               <a:rPr lang="en-US" smtClean="0"/>
-              <a:t>7/21/2026</a:t>
+              <a:t>8/17/2026</a:t>
             </a:fld>
             <a:endParaRPr lang="en-US"/>
           </a:p>
@@ -3459,7 +3459,7 @@
           <a:p>
             <a:fld id="{76F9A3AD-E74E-40F3-A091-AD7A5FD22E1E}" type="datetimeFigureOut">
               <a:rPr lang="en-US" smtClean="0"/>
-              <a:t>7/21/2026</a:t>
+              <a:t>8/17/2026</a:t>
             </a:fld>
             <a:endParaRPr lang="en-US"/>
           </a:p>
@@ -4197,8 +4197,17 @@
         </p:nvPicPr>
         <p:blipFill>
           <a:blip r:embed="rId3">
-            <a:alphaModFix amt="20000"/>
-            <a:extLst>
+            <a:alphaModFix amt="85000"/>
+            <a:extLst>
+              <a:ext uri="{BEBA8EAE-BF5A-486C-A8C5-ECC9F3942E4B}">
+                <a14:imgProps xmlns:a14="http://schemas.microsoft.com/office/drawing/2010/main">
+                  <a14:imgLayer r:embed="rId4">
+                    <a14:imgEffect>
+                      <a14:saturation sat="0"/>
+                    </a14:imgEffect>
+                  </a14:imgLayer>
+                </a14:imgProps>
+              </a:ext>
               <a:ext uri="{28A0092B-C50C-407E-A947-70E740481C1C}">
                 <a14:useLocalDpi xmlns:a14="http://schemas.microsoft.com/office/drawing/2010/main" val="0"/>
               </a:ext>
@@ -4231,6 +4240,11 @@
             <a:chOff x="0" y="0"/>
             <a:chExt cx="2796884" cy="3202683"/>
           </a:xfrm>
+          <a:solidFill>
+            <a:schemeClr val="bg1">
+              <a:lumMod val="85000"/>
+            </a:schemeClr>
+          </a:solidFill>
         </p:grpSpPr>
         <p:sp>
           <p:nvSpPr>
@@ -4267,9 +4281,7 @@
                 </a:path>
               </a:pathLst>
             </a:custGeom>
-            <a:solidFill>
-              <a:srgbClr val="DC0E20"/>
-            </a:solidFill>
+            <a:grpFill/>
           </p:spPr>
           <p:txBody>
             <a:bodyPr/>
@@ -4293,6 +4305,7 @@
             <a:prstGeom prst="rect">
               <a:avLst/>
             </a:prstGeom>
+            <a:grpFill/>
           </p:spPr>
           <p:txBody>
             <a:bodyPr lIns="50800" tIns="50800" rIns="50800" bIns="50800" rtlCol="0" anchor="ctr"/>
@@ -4424,9 +4437,6 @@
             </a:pPr>
             <a:r>
               <a:rPr lang="en-US" sz="3500" dirty="0">
-                <a:solidFill>
-                  <a:srgbClr val="FFFFFF"/>
-                </a:solidFill>
                 <a:latin typeface="Bahnschrift SemiBold" panose="020B0502040204020203" pitchFamily="34" charset="0"/>
                 <a:ea typeface="Canva Sans"/>
                 <a:cs typeface="Canva Sans"/>
@@ -4442,9 +4452,6 @@
               </a:lnSpc>
             </a:pPr>
             <a:endParaRPr lang="en-US" sz="3500" dirty="0">
-              <a:solidFill>
-                <a:srgbClr val="FFFFFF"/>
-              </a:solidFill>
               <a:latin typeface="Bahnschrift SemiBold" panose="020B0502040204020203" pitchFamily="34" charset="0"/>
               <a:ea typeface="Canva Sans"/>
               <a:cs typeface="Canva Sans"/>
@@ -4459,9 +4466,6 @@
             </a:pPr>
             <a:r>
               <a:rPr lang="en-US" sz="3200" dirty="0">
-                <a:solidFill>
-                  <a:srgbClr val="FFFFFF"/>
-                </a:solidFill>
                 <a:latin typeface="Montserrat" panose="00000500000000000000" pitchFamily="2" charset="0"/>
                 <a:ea typeface="Canva Sans"/>
                 <a:cs typeface="Canva Sans"/>
@@ -4477,9 +4481,6 @@
               </a:lnSpc>
             </a:pPr>
             <a:endParaRPr lang="en-US" sz="3600" dirty="0">
-              <a:solidFill>
-                <a:srgbClr val="FFFFFF"/>
-              </a:solidFill>
               <a:latin typeface="Montserrat"/>
               <a:ea typeface="Montserrat"/>
               <a:cs typeface="Montserrat"/>
@@ -4494,9 +4495,6 @@
             </a:pPr>
             <a:r>
               <a:rPr lang="en-US" sz="3500" b="1" dirty="0">
-                <a:solidFill>
-                  <a:srgbClr val="FFFFFF"/>
-                </a:solidFill>
                 <a:latin typeface="Bahnschrift SemiBold" panose="020B0502040204020203" pitchFamily="34" charset="0"/>
                 <a:ea typeface="Canva Sans Bold"/>
                 <a:cs typeface="Canva Sans Bold"/>
@@ -4512,9 +4510,6 @@
               </a:lnSpc>
             </a:pPr>
             <a:endParaRPr lang="en-US" sz="3500" b="1" dirty="0">
-              <a:solidFill>
-                <a:srgbClr val="FFFFFF"/>
-              </a:solidFill>
               <a:latin typeface="Canva Sans Bold"/>
               <a:ea typeface="Canva Sans Bold"/>
               <a:cs typeface="Canva Sans Bold"/>
@@ -4529,9 +4524,6 @@
             </a:pPr>
             <a:r>
               <a:rPr lang="en-US" sz="3200" dirty="0">
-                <a:solidFill>
-                  <a:srgbClr val="FFFFFF"/>
-                </a:solidFill>
                 <a:latin typeface="Montserrat"/>
                 <a:ea typeface="Montserrat"/>
                 <a:cs typeface="Montserrat"/>
@@ -4777,6 +4769,54 @@
           </a:p>
         </p:txBody>
       </p:sp>
+      <p:sp>
+        <p:nvSpPr>
+          <p:cNvPr id="14" name="TextBox 8">
+            <a:extLst>
+              <a:ext uri="{FF2B5EF4-FFF2-40B4-BE49-F238E27FC236}">
+                <a16:creationId xmlns:a16="http://schemas.microsoft.com/office/drawing/2014/main" id="{D13D0D64-240A-3C03-8C7E-D8A1C13EF47C}"/>
+              </a:ext>
+            </a:extLst>
+          </p:cNvPr>
+          <p:cNvSpPr txBox="1"/>
+          <p:nvPr/>
+        </p:nvSpPr>
+        <p:spPr>
+          <a:xfrm>
+            <a:off x="228599" y="155335"/>
+            <a:ext cx="8266726" cy="1045777"/>
+          </a:xfrm>
+          <a:prstGeom prst="rect">
+            <a:avLst/>
+          </a:prstGeom>
+        </p:spPr>
+        <p:style>
+          <a:lnRef idx="2">
+            <a:schemeClr val="accent1"/>
+          </a:lnRef>
+          <a:fillRef idx="1">
+            <a:schemeClr val="lt1"/>
+          </a:fillRef>
+          <a:effectRef idx="0">
+            <a:schemeClr val="accent1"/>
+          </a:effectRef>
+          <a:fontRef idx="minor">
+            <a:schemeClr val="dk1"/>
+          </a:fontRef>
+        </p:style>
+        <p:txBody>
+          <a:bodyPr lIns="50800" tIns="50800" rIns="50800" bIns="50800" rtlCol="0" anchor="ctr"/>
+          <a:lstStyle/>
+          <a:p>
+            <a:pPr algn="ctr">
+              <a:lnSpc>
+                <a:spcPts val="2661"/>
+              </a:lnSpc>
+            </a:pPr>
+            <a:endParaRPr/>
+          </a:p>
+        </p:txBody>
+      </p:sp>
       <p:pic>
         <p:nvPicPr>
           <p:cNvPr id="3" name="Picture 2">
@@ -4792,7 +4832,7 @@
           <p:nvPr/>
         </p:nvPicPr>
         <p:blipFill>
-          <a:blip r:embed="rId4" cstate="print">
+          <a:blip r:embed="rId5" cstate="print">
             <a:extLst>
               <a:ext uri="{28A0092B-C50C-407E-A947-70E740481C1C}">
                 <a14:useLocalDpi xmlns:a14="http://schemas.microsoft.com/office/drawing/2010/main" val="0"/>
@@ -4805,8 +4845,44 @@
         </p:blipFill>
         <p:spPr>
           <a:xfrm>
-            <a:off x="152400" y="284788"/>
-            <a:ext cx="2699385" cy="878224"/>
+            <a:off x="186265" y="129530"/>
+            <a:ext cx="3691841" cy="1201112"/>
+          </a:xfrm>
+          <a:prstGeom prst="rect">
+            <a:avLst/>
+          </a:prstGeom>
+        </p:spPr>
+      </p:pic>
+      <p:pic>
+        <p:nvPicPr>
+          <p:cNvPr id="19" name="Picture 18">
+            <a:extLst>
+              <a:ext uri="{FF2B5EF4-FFF2-40B4-BE49-F238E27FC236}">
+                <a16:creationId xmlns:a16="http://schemas.microsoft.com/office/drawing/2014/main" id="{FB863FBF-FD46-F411-64A8-93C00FE46EB4}"/>
+              </a:ext>
+            </a:extLst>
+          </p:cNvPr>
+          <p:cNvPicPr>
+            <a:picLocks noChangeAspect="1"/>
+          </p:cNvPicPr>
+          <p:nvPr/>
+        </p:nvPicPr>
+        <p:blipFill>
+          <a:blip r:embed="rId6" cstate="print">
+            <a:extLst>
+              <a:ext uri="{28A0092B-C50C-407E-A947-70E740481C1C}">
+                <a14:useLocalDpi xmlns:a14="http://schemas.microsoft.com/office/drawing/2010/main" val="0"/>
+              </a:ext>
+            </a:extLst>
+          </a:blip>
+          <a:stretch>
+            <a:fillRect/>
+          </a:stretch>
+        </p:blipFill>
+        <p:spPr>
+          <a:xfrm>
+            <a:off x="4227097" y="-1562100"/>
+            <a:ext cx="4431326" cy="4431326"/>
           </a:xfrm>
           <a:prstGeom prst="rect">
             <a:avLst/>

</xml_diff>